<commit_message>
slides(course): regenerate claude-tool-use-from-zero ch07 deck [KOEA-4862]
</commit_message>
<xml_diff>
--- a/vault/courses/claude-tool-use-from-zero/ch07-slides.pptx
+++ b/vault/courses/claude-tool-use-from-zero/ch07-slides.pptx
@@ -3110,8 +3110,8 @@
         </p:nvSpPr>
         <p:spPr>
           <a:xfrm>
-            <a:off x="731520" y="1417320"/>
-            <a:ext cx="10744200" cy="1920240"/>
+            <a:off x="914400" y="1828800"/>
+            <a:ext cx="10332720" cy="2286000"/>
           </a:xfrm>
           <a:prstGeom prst="rect">
             <a:avLst/>
@@ -3131,7 +3131,7 @@
                   <a:srgbClr val="FFFFFF"/>
                 </a:solidFill>
               </a:rPr>
-              <a:t>How to use Claude's creative connectors for Blender and Adobe for creativity</a:t>
+              <a:t>Creative Connectors</a:t>
             </a:r>
           </a:p>
         </p:txBody>
@@ -3144,76 +3144,8 @@
         </p:nvSpPr>
         <p:spPr>
           <a:xfrm>
-            <a:off x="731520" y="3611880"/>
-            <a:ext cx="10744200" cy="457200"/>
-          </a:xfrm>
-          <a:prstGeom prst="rect">
-            <a:avLst/>
-          </a:prstGeom>
-          <a:noFill/>
-        </p:spPr>
-        <p:txBody>
-          <a:bodyPr wrap="square">
-            <a:spAutoFit/>
-          </a:bodyPr>
-          <a:lstStyle/>
-          <a:p>
-            <a:pPr algn="ctr"/>
-            <a:r>
-              <a:rPr sz="1700" b="0">
-                <a:solidFill>
-                  <a:srgbClr val="A1A1AA"/>
-                </a:solidFill>
-              </a:rPr>
-              <a:t>Chapter 7 · Claude Tool Use from Zero</a:t>
-            </a:r>
-          </a:p>
-        </p:txBody>
-      </p:sp>
-      <p:sp>
-        <p:nvSpPr>
-          <p:cNvPr id="4" name="TextBox 3"/>
-          <p:cNvSpPr txBox="1"/>
-          <p:nvPr/>
-        </p:nvSpPr>
-        <p:spPr>
-          <a:xfrm>
-            <a:off x="1234440" y="4343400"/>
-            <a:ext cx="9784080" cy="731520"/>
-          </a:xfrm>
-          <a:prstGeom prst="rect">
-            <a:avLst/>
-          </a:prstGeom>
-          <a:noFill/>
-        </p:spPr>
-        <p:txBody>
-          <a:bodyPr wrap="square">
-            <a:spAutoFit/>
-          </a:bodyPr>
-          <a:lstStyle/>
-          <a:p>
-            <a:pPr algn="ctr"/>
-            <a:r>
-              <a:rPr sz="1800" b="0">
-                <a:solidFill>
-                  <a:srgbClr val="D4D4D8"/>
-                </a:solidFill>
-              </a:rPr>
-              <a:t>Blender execution, Adobe pipelines, connector selection, and resilient fallback design</a:t>
-            </a:r>
-          </a:p>
-        </p:txBody>
-      </p:sp>
-      <p:sp>
-        <p:nvSpPr>
-          <p:cNvPr id="5" name="TextBox 4"/>
-          <p:cNvSpPr txBox="1"/>
-          <p:nvPr/>
-        </p:nvSpPr>
-        <p:spPr>
-          <a:xfrm>
-            <a:off x="731520" y="6272784"/>
-            <a:ext cx="10789920" cy="274320"/>
+            <a:off x="731520" y="6263640"/>
+            <a:ext cx="10698480" cy="365760"/>
           </a:xfrm>
           <a:prstGeom prst="rect">
             <a:avLst/>
@@ -3273,7 +3205,7 @@
         <p:spPr>
           <a:xfrm>
             <a:off x="731520" y="411480"/>
-            <a:ext cx="10698480" cy="685800"/>
+            <a:ext cx="10698480" cy="1005840"/>
           </a:xfrm>
           <a:prstGeom prst="rect">
             <a:avLst/>
@@ -3293,7 +3225,7 @@
                   <a:srgbClr val="FFFFFF"/>
                 </a:solidFill>
               </a:rPr>
-              <a:t>Why Creative Connectors Matter</a:t>
+              <a:t>Key facts</a:t>
             </a:r>
           </a:p>
         </p:txBody>
@@ -3306,8 +3238,8 @@
         </p:nvSpPr>
         <p:spPr>
           <a:xfrm>
-            <a:off x="731520" y="1234440"/>
-            <a:ext cx="10698480" cy="32004"/>
+            <a:off x="731520" y="1417320"/>
+            <a:ext cx="10698480" cy="36576"/>
           </a:xfrm>
           <a:prstGeom prst="rect">
             <a:avLst/>
@@ -3349,8 +3281,8 @@
         </p:nvSpPr>
         <p:spPr>
           <a:xfrm>
-            <a:off x="914400" y="1572768"/>
-            <a:ext cx="10149840" cy="658368"/>
+            <a:off x="731520" y="1600200"/>
+            <a:ext cx="10698480" cy="960120"/>
           </a:xfrm>
           <a:prstGeom prst="rect">
             <a:avLst/>
@@ -3365,12 +3297,12 @@
           <a:p>
             <a:pPr algn="l"/>
             <a:r>
-              <a:rPr sz="1800" b="0">
+              <a:rPr sz="1700" b="0">
                 <a:solidFill>
                   <a:srgbClr val="FFFFFF"/>
                 </a:solidFill>
               </a:rPr>
-              <a:t>• Anthropic launched nine creative MCP connectors spanning 3D, design, audio, CAD, live visuals, and samples</a:t>
+              <a:t>  Nine initial connectors: The launch includes Blender, Adobe for creativity, Ableton Live, Affinity by Canva, Autodesk Fusion, SketchUp, Reso</a:t>
             </a:r>
           </a:p>
         </p:txBody>
@@ -3383,8 +3315,8 @@
         </p:nvSpPr>
         <p:spPr>
           <a:xfrm>
-            <a:off x="914400" y="2414016"/>
-            <a:ext cx="10149840" cy="658368"/>
+            <a:off x="731520" y="2651760"/>
+            <a:ext cx="10698480" cy="960120"/>
           </a:xfrm>
           <a:prstGeom prst="rect">
             <a:avLst/>
@@ -3399,12 +3331,12 @@
           <a:p>
             <a:pPr algn="l"/>
             <a:r>
-              <a:rPr sz="1800" b="0">
+              <a:rPr sz="1700" b="0">
                 <a:solidFill>
                   <a:srgbClr val="FFFFFF"/>
                 </a:solidFill>
               </a:rPr>
-              <a:t>• Creative apps have high syntax barriers, which makes tool-use wins visible quickly</a:t>
+              <a:t>  Live scene execution: Unlike static file parsing, connectors like Blender allow Claude to execute code (via bpy) against the live scene stat</a:t>
             </a:r>
           </a:p>
         </p:txBody>
@@ -3417,8 +3349,8 @@
         </p:nvSpPr>
         <p:spPr>
           <a:xfrm>
-            <a:off x="914400" y="3255264"/>
-            <a:ext cx="10149840" cy="658368"/>
+            <a:off x="731520" y="3703320"/>
+            <a:ext cx="10698480" cy="960120"/>
           </a:xfrm>
           <a:prstGeom prst="rect">
             <a:avLst/>
@@ -3433,12 +3365,12 @@
           <a:p>
             <a:pPr algn="l"/>
             <a:r>
-              <a:rPr sz="1800" b="0">
+              <a:rPr sz="1700" b="0">
                 <a:solidFill>
                   <a:srgbClr val="FFFFFF"/>
                 </a:solidFill>
               </a:rPr>
-              <a:t>• Local MCP servers keep asset operations close to the machine running the professional software</a:t>
+              <a:t>  Local-first architecture: The connectors run as local MCP servers, meaning your creative assets stay on your machine while Claude only sends</a:t>
             </a:r>
           </a:p>
         </p:txBody>
@@ -3451,8 +3383,8 @@
         </p:nvSpPr>
         <p:spPr>
           <a:xfrm>
-            <a:off x="914400" y="4096512"/>
-            <a:ext cx="10149840" cy="658368"/>
+            <a:off x="731520" y="4754880"/>
+            <a:ext cx="10698480" cy="960120"/>
           </a:xfrm>
           <a:prstGeom prst="rect">
             <a:avLst/>
@@ -3467,12 +3399,12 @@
           <a:p>
             <a:pPr algn="l"/>
             <a:r>
-              <a:rPr sz="1800" b="0">
+              <a:rPr sz="1700" b="0">
                 <a:solidFill>
                   <a:srgbClr val="FFFFFF"/>
                 </a:solidFill>
               </a:rPr>
-              <a:t>• Cross-app workflows turn Claude into coordination infrastructure for fragmented creative suites</a:t>
+              <a:t>  Free and Paid Tiers: While many features (like Adobe Express) are available on free plans, advanced API access for tools like Photoshop typi</a:t>
             </a:r>
           </a:p>
         </p:txBody>
@@ -3485,8 +3417,8 @@
         </p:nvSpPr>
         <p:spPr>
           <a:xfrm>
-            <a:off x="731520" y="6272784"/>
-            <a:ext cx="10789920" cy="274320"/>
+            <a:off x="731520" y="6263640"/>
+            <a:ext cx="10698480" cy="365760"/>
           </a:xfrm>
           <a:prstGeom prst="rect">
             <a:avLst/>
@@ -3546,7 +3478,7 @@
         <p:spPr>
           <a:xfrm>
             <a:off x="731520" y="411480"/>
-            <a:ext cx="10698480" cy="685800"/>
+            <a:ext cx="10698480" cy="1005840"/>
           </a:xfrm>
           <a:prstGeom prst="rect">
             <a:avLst/>
@@ -3566,7 +3498,7 @@
                   <a:srgbClr val="FFFFFF"/>
                 </a:solidFill>
               </a:rPr>
-              <a:t>Blender MCP: Live Scene Execution</a:t>
+              <a:t>Why Anthropic chose creative apps first</a:t>
             </a:r>
           </a:p>
         </p:txBody>
@@ -3579,8 +3511,8 @@
         </p:nvSpPr>
         <p:spPr>
           <a:xfrm>
-            <a:off x="731520" y="1234440"/>
-            <a:ext cx="10698480" cy="32004"/>
+            <a:off x="731520" y="1417320"/>
+            <a:ext cx="10698480" cy="36576"/>
           </a:xfrm>
           <a:prstGeom prst="rect">
             <a:avLst/>
@@ -3622,8 +3554,8 @@
         </p:nvSpPr>
         <p:spPr>
           <a:xfrm>
-            <a:off x="914400" y="1572768"/>
-            <a:ext cx="10149840" cy="658368"/>
+            <a:off x="731520" y="1600200"/>
+            <a:ext cx="10698480" cy="960120"/>
           </a:xfrm>
           <a:prstGeom prst="rect">
             <a:avLst/>
@@ -3638,12 +3570,12 @@
           <a:p>
             <a:pPr algn="l"/>
             <a:r>
-              <a:rPr sz="1800" b="0">
+              <a:rPr sz="1700" b="0">
                 <a:solidFill>
                   <a:srgbClr val="FFFFFF"/>
                 </a:solidFill>
               </a:rPr>
-              <a:t>• The Blender connector exposes Blender Python through an MCP tool interface</a:t>
+              <a:t>  Most AI providers chase enterprise CRM and ERP integrations. Anthropic’s pivot to creative tools is non-obvious but brilliant for three reas</a:t>
             </a:r>
           </a:p>
         </p:txBody>
@@ -3656,8 +3588,8 @@
         </p:nvSpPr>
         <p:spPr>
           <a:xfrm>
-            <a:off x="914400" y="2414016"/>
-            <a:ext cx="10149840" cy="658368"/>
+            <a:off x="731520" y="2651760"/>
+            <a:ext cx="10698480" cy="960120"/>
           </a:xfrm>
           <a:prstGeom prst="rect">
             <a:avLst/>
@@ -3672,12 +3604,12 @@
           <a:p>
             <a:pPr algn="l"/>
             <a:r>
-              <a:rPr sz="1800" b="0">
+              <a:rPr sz="1700" b="0">
                 <a:solidFill>
                   <a:srgbClr val="FFFFFF"/>
                 </a:solidFill>
               </a:rPr>
-              <a:t>• Claude sends structured execute_python calls that run inside Blender against live scene state</a:t>
+              <a:t>  High Syntax Barrier: Writing bpy (Blender Python) or ExtendScript (Adobe) is notoriously difficult for humans but easy for LLMs. This create</a:t>
             </a:r>
           </a:p>
         </p:txBody>
@@ -3690,8 +3622,8 @@
         </p:nvSpPr>
         <p:spPr>
           <a:xfrm>
-            <a:off x="914400" y="3255264"/>
-            <a:ext cx="10149840" cy="658368"/>
+            <a:off x="731520" y="3703320"/>
+            <a:ext cx="10698480" cy="960120"/>
           </a:xfrm>
           <a:prstGeom prst="rect">
             <a:avLst/>
@@ -3706,12 +3638,12 @@
           <a:p>
             <a:pPr algn="l"/>
             <a:r>
-              <a:rPr sz="1800" b="0">
+              <a:rPr sz="1700" b="0">
                 <a:solidFill>
                   <a:srgbClr val="FFFFFF"/>
                 </a:solidFill>
               </a:rPr>
-              <a:t>• A safe first step is a read-only query that lists scene objects and types</a:t>
+              <a:t>  Low Risk, High Visibility: A bug in a generative 3D script is a creative glitch; a bug in a Salesforce integration is a business catastrophe</a:t>
             </a:r>
           </a:p>
         </p:txBody>
@@ -3724,8 +3656,8 @@
         </p:nvSpPr>
         <p:spPr>
           <a:xfrm>
-            <a:off x="914400" y="4096512"/>
-            <a:ext cx="10149840" cy="658368"/>
+            <a:off x="731520" y="4754880"/>
+            <a:ext cx="10698480" cy="960120"/>
           </a:xfrm>
           <a:prstGeom prst="rect">
             <a:avLst/>
@@ -3740,12 +3672,12 @@
           <a:p>
             <a:pPr algn="l"/>
             <a:r>
-              <a:rPr sz="1800" b="0">
+              <a:rPr sz="1700" b="0">
                 <a:solidFill>
                   <a:srgbClr val="FFFFFF"/>
                 </a:solidFill>
               </a:rPr>
-              <a:t>• Procedural generation becomes repeatable when scripts use stable collections and object names</a:t>
+              <a:t>  Synthesizing the Pipeline: Creative work is rarely done in one app. By winning the "bridge" between Blender and Photoshop, Anthropic positio</a:t>
             </a:r>
           </a:p>
         </p:txBody>
@@ -3758,8 +3690,8 @@
         </p:nvSpPr>
         <p:spPr>
           <a:xfrm>
-            <a:off x="731520" y="6272784"/>
-            <a:ext cx="10789920" cy="274320"/>
+            <a:off x="731520" y="6263640"/>
+            <a:ext cx="10698480" cy="365760"/>
           </a:xfrm>
           <a:prstGeom prst="rect">
             <a:avLst/>
@@ -3819,7 +3751,7 @@
         <p:spPr>
           <a:xfrm>
             <a:off x="731520" y="411480"/>
-            <a:ext cx="10698480" cy="685800"/>
+            <a:ext cx="10698480" cy="1005840"/>
           </a:xfrm>
           <a:prstGeom prst="rect">
             <a:avLst/>
@@ -3839,7 +3771,7 @@
                   <a:srgbClr val="FFFFFF"/>
                 </a:solidFill>
               </a:rPr>
-              <a:t>Adobe For Creativity: Locate, Edit, Export</a:t>
+              <a:t>Walkthrough: Controlling Blender via MCP</a:t>
             </a:r>
           </a:p>
         </p:txBody>
@@ -3852,8 +3784,8 @@
         </p:nvSpPr>
         <p:spPr>
           <a:xfrm>
-            <a:off x="731520" y="1234440"/>
-            <a:ext cx="10698480" cy="32004"/>
+            <a:off x="731520" y="1417320"/>
+            <a:ext cx="10698480" cy="36576"/>
           </a:xfrm>
           <a:prstGeom prst="rect">
             <a:avLst/>
@@ -3895,8 +3827,8 @@
         </p:nvSpPr>
         <p:spPr>
           <a:xfrm>
-            <a:off x="914400" y="1572768"/>
-            <a:ext cx="10149840" cy="658368"/>
+            <a:off x="731520" y="1600200"/>
+            <a:ext cx="10698480" cy="960120"/>
           </a:xfrm>
           <a:prstGeom prst="rect">
             <a:avLst/>
@@ -3911,12 +3843,12 @@
           <a:p>
             <a:pPr algn="l"/>
             <a:r>
-              <a:rPr sz="1800" b="0">
+              <a:rPr sz="1700" b="0">
                 <a:solidFill>
                   <a:srgbClr val="FFFFFF"/>
                 </a:solidFill>
               </a:rPr>
-              <a:t>• The Adobe connector wraps multiple creative applications under one tool-use surface</a:t>
+              <a:t>  The Blender connector is the most technically transparent of Anthropic's nine creative integrations. Unlike connectors that wrap proprietary</a:t>
             </a:r>
           </a:p>
         </p:txBody>
@@ -3929,8 +3861,8 @@
         </p:nvSpPr>
         <p:spPr>
           <a:xfrm>
-            <a:off x="914400" y="2414016"/>
-            <a:ext cx="10149840" cy="658368"/>
+            <a:off x="731520" y="2651760"/>
+            <a:ext cx="10698480" cy="960120"/>
           </a:xfrm>
           <a:prstGeom prst="rect">
             <a:avLst/>
@@ -3945,12 +3877,12 @@
           <a:p>
             <a:pPr algn="l"/>
             <a:r>
-              <a:rPr sz="1800" b="0">
+              <a:rPr sz="1700" b="0">
                 <a:solidFill>
                   <a:srgbClr val="FFFFFF"/>
                 </a:solidFill>
               </a:rPr>
-              <a:t>• A pipeline can search a Library asset, open it in Photoshop, apply a Smart Filter, and export a JPEG</a:t>
+              <a:t>  How the connection works</a:t>
             </a:r>
           </a:p>
         </p:txBody>
@@ -3963,8 +3895,8 @@
         </p:nvSpPr>
         <p:spPr>
           <a:xfrm>
-            <a:off x="914400" y="3255264"/>
-            <a:ext cx="10149840" cy="658368"/>
+            <a:off x="731520" y="3703320"/>
+            <a:ext cx="10698480" cy="960120"/>
           </a:xfrm>
           <a:prstGeom prst="rect">
             <a:avLst/>
@@ -3979,12 +3911,12 @@
           <a:p>
             <a:pPr algn="l"/>
             <a:r>
-              <a:rPr sz="1800" b="0">
+              <a:rPr sz="1700" b="0">
                 <a:solidFill>
                   <a:srgbClr val="FFFFFF"/>
                 </a:solidFill>
               </a:rPr>
-              <a:t>• Smart Objects keep edits non-destructive so filters remain adjustable later</a:t>
+              <a:t>  Before touching any code, it helps to have a mental model of the data flow.</a:t>
             </a:r>
           </a:p>
         </p:txBody>
@@ -3997,8 +3929,8 @@
         </p:nvSpPr>
         <p:spPr>
           <a:xfrm>
-            <a:off x="914400" y="4096512"/>
-            <a:ext cx="10149840" cy="658368"/>
+            <a:off x="731520" y="4754880"/>
+            <a:ext cx="10698480" cy="960120"/>
           </a:xfrm>
           <a:prstGeom prst="rect">
             <a:avLst/>
@@ -4013,12 +3945,12 @@
           <a:p>
             <a:pPr algn="l"/>
             <a:r>
-              <a:rPr sz="1800" b="0">
+              <a:rPr sz="1700" b="0">
                 <a:solidFill>
                   <a:srgbClr val="FFFFFF"/>
                 </a:solidFill>
               </a:rPr>
-              <a:t>• Plan subscriptions matter: Adobe Express can be free, while Photoshop and Library write flows usually need paid access</a:t>
+              <a:t>  You (natural language)</a:t>
             </a:r>
           </a:p>
         </p:txBody>
@@ -4031,8 +3963,8 @@
         </p:nvSpPr>
         <p:spPr>
           <a:xfrm>
-            <a:off x="731520" y="6272784"/>
-            <a:ext cx="10789920" cy="274320"/>
+            <a:off x="731520" y="6263640"/>
+            <a:ext cx="10698480" cy="365760"/>
           </a:xfrm>
           <a:prstGeom prst="rect">
             <a:avLst/>
@@ -4092,7 +4024,7 @@
         <p:spPr>
           <a:xfrm>
             <a:off x="731520" y="411480"/>
-            <a:ext cx="10698480" cy="685800"/>
+            <a:ext cx="10698480" cy="1005840"/>
           </a:xfrm>
           <a:prstGeom prst="rect">
             <a:avLst/>
@@ -4112,7 +4044,7 @@
                   <a:srgbClr val="FFFFFF"/>
                 </a:solidFill>
               </a:rPr>
-              <a:t>Choosing The Right Connector</a:t>
+              <a:t>Walkthrough: Multi-tool pipelines with Adobe for creativity</a:t>
             </a:r>
           </a:p>
         </p:txBody>
@@ -4125,8 +4057,8 @@
         </p:nvSpPr>
         <p:spPr>
           <a:xfrm>
-            <a:off x="731520" y="1234440"/>
-            <a:ext cx="10698480" cy="32004"/>
+            <a:off x="731520" y="1417320"/>
+            <a:ext cx="10698480" cy="36576"/>
           </a:xfrm>
           <a:prstGeom prst="rect">
             <a:avLst/>
@@ -4168,8 +4100,8 @@
         </p:nvSpPr>
         <p:spPr>
           <a:xfrm>
-            <a:off x="914400" y="1572768"/>
-            <a:ext cx="10149840" cy="658368"/>
+            <a:off x="731520" y="1600200"/>
+            <a:ext cx="10698480" cy="960120"/>
           </a:xfrm>
           <a:prstGeom prst="rect">
             <a:avLst/>
@@ -4184,12 +4116,12 @@
           <a:p>
             <a:pPr algn="l"/>
             <a:r>
-              <a:rPr sz="1800" b="0">
+              <a:rPr sz="1700" b="0">
                 <a:solidFill>
                   <a:srgbClr val="FFFFFF"/>
                 </a:solidFill>
               </a:rPr>
-              <a:t>• Use Blender for generative scenes and procedural 3D work driven by Python APIs</a:t>
+              <a:t>  Adobe for creativity is the broadest integration in Anthropic's creative connector lineup: a broad collection of tools across photo editing,</a:t>
             </a:r>
           </a:p>
         </p:txBody>
@@ -4202,8 +4134,8 @@
         </p:nvSpPr>
         <p:spPr>
           <a:xfrm>
-            <a:off x="914400" y="2414016"/>
-            <a:ext cx="10149840" cy="658368"/>
+            <a:off x="731520" y="2651760"/>
+            <a:ext cx="10698480" cy="960120"/>
           </a:xfrm>
           <a:prstGeom prst="rect">
             <a:avLst/>
@@ -4218,12 +4150,12 @@
           <a:p>
             <a:pPr algn="l"/>
             <a:r>
-              <a:rPr sz="1800" b="0">
+              <a:rPr sz="1700" b="0">
                 <a:solidFill>
                   <a:srgbClr val="FFFFFF"/>
                 </a:solidFill>
               </a:rPr>
-              <a:t>• Use Adobe or Affinity when the workflow centers on design assets, layers, batches, or exports</a:t>
+              <a:t>  What requires a paid plan</a:t>
             </a:r>
           </a:p>
         </p:txBody>
@@ -4236,8 +4168,8 @@
         </p:nvSpPr>
         <p:spPr>
           <a:xfrm>
-            <a:off x="914400" y="3255264"/>
-            <a:ext cx="10149840" cy="658368"/>
+            <a:off x="731520" y="3703320"/>
+            <a:ext cx="10698480" cy="960120"/>
           </a:xfrm>
           <a:prstGeom prst="rect">
             <a:avLst/>
@@ -4252,12 +4184,12 @@
           <a:p>
             <a:pPr algn="l"/>
             <a:r>
-              <a:rPr sz="1800" b="0">
+              <a:rPr sz="1700" b="0">
                 <a:solidFill>
                   <a:srgbClr val="FFFFFF"/>
                 </a:solidFill>
               </a:rPr>
-              <a:t>• Use Fusion or SketchUp when precision geometry and CAD constraints are the core task</a:t>
+              <a:t>  Multi-tool flow: locate → edit → export</a:t>
             </a:r>
           </a:p>
         </p:txBody>
@@ -4270,8 +4202,8 @@
         </p:nvSpPr>
         <p:spPr>
           <a:xfrm>
-            <a:off x="914400" y="4096512"/>
-            <a:ext cx="10149840" cy="658368"/>
+            <a:off x="731520" y="4754880"/>
+            <a:ext cx="10698480" cy="960120"/>
           </a:xfrm>
           <a:prstGeom prst="rect">
             <a:avLst/>
@@ -4286,12 +4218,12 @@
           <a:p>
             <a:pPr algn="l"/>
             <a:r>
-              <a:rPr sz="1800" b="0">
+              <a:rPr sz="1700" b="0">
                 <a:solidFill>
                   <a:srgbClr val="FFFFFF"/>
                 </a:solidFill>
               </a:rPr>
-              <a:t>• Use Ableton, Splice, or Resolume when the asset is audio, samples, or live visual performance state</a:t>
+              <a:t>  Each step here is a separate tool call; Claude sequences them automatically based on context.</a:t>
             </a:r>
           </a:p>
         </p:txBody>
@@ -4304,8 +4236,8 @@
         </p:nvSpPr>
         <p:spPr>
           <a:xfrm>
-            <a:off x="731520" y="6272784"/>
-            <a:ext cx="10789920" cy="274320"/>
+            <a:off x="731520" y="6263640"/>
+            <a:ext cx="10698480" cy="365760"/>
           </a:xfrm>
           <a:prstGeom prst="rect">
             <a:avLst/>
@@ -4365,7 +4297,7 @@
         <p:spPr>
           <a:xfrm>
             <a:off x="731520" y="411480"/>
-            <a:ext cx="10698480" cy="685800"/>
+            <a:ext cx="10698480" cy="1005840"/>
           </a:xfrm>
           <a:prstGeom prst="rect">
             <a:avLst/>
@@ -4385,7 +4317,7 @@
                   <a:srgbClr val="FFFFFF"/>
                 </a:solidFill>
               </a:rPr>
-              <a:t>Build Resilience Into Creative Pipelines</a:t>
+              <a:t>Exploring the other creative connectors</a:t>
             </a:r>
           </a:p>
         </p:txBody>
@@ -4398,8 +4330,8 @@
         </p:nvSpPr>
         <p:spPr>
           <a:xfrm>
-            <a:off x="731520" y="1234440"/>
-            <a:ext cx="10698480" cy="32004"/>
+            <a:off x="731520" y="1417320"/>
+            <a:ext cx="10698480" cy="36576"/>
           </a:xfrm>
           <a:prstGeom prst="rect">
             <a:avLst/>
@@ -4441,8 +4373,8 @@
         </p:nvSpPr>
         <p:spPr>
           <a:xfrm>
-            <a:off x="914400" y="1572768"/>
-            <a:ext cx="10149840" cy="658368"/>
+            <a:off x="731520" y="1600200"/>
+            <a:ext cx="10698480" cy="960120"/>
           </a:xfrm>
           <a:prstGeom prst="rect">
             <a:avLst/>
@@ -4457,12 +4389,12 @@
           <a:p>
             <a:pPr algn="l"/>
             <a:r>
-              <a:rPr sz="1800" b="0">
+              <a:rPr sz="1700" b="0">
                 <a:solidFill>
                   <a:srgbClr val="FFFFFF"/>
                 </a:solidFill>
               </a:rPr>
-              <a:t>• Claude is a strong first-choice model, but single-provider dependency can halt production during outages</a:t>
+              <a:t>  While Blender and Adobe for creativity are the flagship integrations, Anthropic launched a total of nine connectors targeting different crea</a:t>
             </a:r>
           </a:p>
         </p:txBody>
@@ -4475,8 +4407,8 @@
         </p:nvSpPr>
         <p:spPr>
           <a:xfrm>
-            <a:off x="914400" y="2414016"/>
-            <a:ext cx="10149840" cy="658368"/>
+            <a:off x="731520" y="2651760"/>
+            <a:ext cx="10698480" cy="960120"/>
           </a:xfrm>
           <a:prstGeom prst="rect">
             <a:avLst/>
@@ -4491,12 +4423,12 @@
           <a:p>
             <a:pPr algn="l"/>
             <a:r>
-              <a:rPr sz="1800" b="0">
+              <a:rPr sz="1700" b="0">
                 <a:solidFill>
                   <a:srgbClr val="FFFFFF"/>
                 </a:solidFill>
               </a:rPr>
-              <a:t>• Keep MCP tool definitions provider-agnostic so fallback models can call the same tools</a:t>
+              <a:t>  Ableton Live: Automating the manual</a:t>
             </a:r>
           </a:p>
         </p:txBody>
@@ -4509,8 +4441,8 @@
         </p:nvSpPr>
         <p:spPr>
           <a:xfrm>
-            <a:off x="914400" y="3255264"/>
-            <a:ext cx="10149840" cy="658368"/>
+            <a:off x="731520" y="3703320"/>
+            <a:ext cx="10698480" cy="960120"/>
           </a:xfrm>
           <a:prstGeom prst="rect">
             <a:avLst/>
@@ -4525,12 +4457,12 @@
           <a:p>
             <a:pPr algn="l"/>
             <a:r>
-              <a:rPr sz="1800" b="0">
+              <a:rPr sz="1700" b="0">
                 <a:solidFill>
                   <a:srgbClr val="FFFFFF"/>
                 </a:solidFill>
               </a:rPr>
-              <a:t>• Implement fallback explicitly in your gateway or application loop instead of assuming the SDK handles it</a:t>
+              <a:t>  The Ableton connector focuses on documentation and session management. It allows Claude to read session metadata (track names, clips, device</a:t>
             </a:r>
           </a:p>
         </p:txBody>
@@ -4543,8 +4475,8 @@
         </p:nvSpPr>
         <p:spPr>
           <a:xfrm>
-            <a:off x="914400" y="4096512"/>
-            <a:ext cx="10149840" cy="658368"/>
+            <a:off x="731520" y="4754880"/>
+            <a:ext cx="10698480" cy="960120"/>
           </a:xfrm>
           <a:prstGeom prst="rect">
             <a:avLst/>
@@ -4559,12 +4491,12 @@
           <a:p>
             <a:pPr algn="l"/>
             <a:r>
-              <a:rPr sz="1800" b="0">
+              <a:rPr sz="1700" b="0">
                 <a:solidFill>
                   <a:srgbClr val="FFFFFF"/>
                 </a:solidFill>
               </a:rPr>
-              <a:t>• Treat uptime, naming conventions, and auditability as part of the creative tool contract</a:t>
+              <a:t>  Pattern: Read session → Analyze MIDI → Generate documentation/labels.</a:t>
             </a:r>
           </a:p>
         </p:txBody>
@@ -4577,8 +4509,8 @@
         </p:nvSpPr>
         <p:spPr>
           <a:xfrm>
-            <a:off x="731520" y="6272784"/>
-            <a:ext cx="10789920" cy="274320"/>
+            <a:off x="731520" y="6263640"/>
+            <a:ext cx="10698480" cy="365760"/>
           </a:xfrm>
           <a:prstGeom prst="rect">
             <a:avLst/>
@@ -4637,8 +4569,8 @@
         </p:nvSpPr>
         <p:spPr>
           <a:xfrm>
-            <a:off x="731520" y="914400"/>
-            <a:ext cx="10698480" cy="822960"/>
+            <a:off x="914400" y="2011680"/>
+            <a:ext cx="10332720" cy="914400"/>
           </a:xfrm>
           <a:prstGeom prst="rect">
             <a:avLst/>
@@ -4671,8 +4603,8 @@
         </p:nvSpPr>
         <p:spPr>
           <a:xfrm>
-            <a:off x="1325880" y="2148840"/>
-            <a:ext cx="9555480" cy="658368"/>
+            <a:off x="914400" y="3200400"/>
+            <a:ext cx="10332720" cy="1097280"/>
           </a:xfrm>
           <a:prstGeom prst="rect">
             <a:avLst/>
@@ -4685,14 +4617,14 @@
           </a:bodyPr>
           <a:lstStyle/>
           <a:p>
-            <a:pPr algn="l"/>
-            <a:r>
-              <a:rPr sz="1800" b="0">
-                <a:solidFill>
-                  <a:srgbClr val="FFFFFF"/>
+            <a:pPr algn="ctr"/>
+            <a:r>
+              <a:rPr sz="2000" b="0">
+                <a:solidFill>
+                  <a:srgbClr val="A1A1AA"/>
                 </a:solidFill>
               </a:rPr>
-              <a:t>• Connect a creative tool in Claude and start with a read-only scene or asset query</a:t>
+              <a:t>Deploy a gateway with RBAC, rate limits, and JSONL auditing</a:t>
             </a:r>
           </a:p>
         </p:txBody>
@@ -4705,144 +4637,8 @@
         </p:nvSpPr>
         <p:spPr>
           <a:xfrm>
-            <a:off x="1325880" y="2898648"/>
-            <a:ext cx="9555480" cy="658368"/>
-          </a:xfrm>
-          <a:prstGeom prst="rect">
-            <a:avLst/>
-          </a:prstGeom>
-          <a:noFill/>
-        </p:spPr>
-        <p:txBody>
-          <a:bodyPr wrap="square">
-            <a:spAutoFit/>
-          </a:bodyPr>
-          <a:lstStyle/>
-          <a:p>
-            <a:pPr algn="l"/>
-            <a:r>
-              <a:rPr sz="1800" b="0">
-                <a:solidFill>
-                  <a:srgbClr val="FFFFFF"/>
-                </a:solidFill>
-              </a:rPr>
-              <a:t>• Automate one repeatable production step before attempting a full multi-app workflow</a:t>
-            </a:r>
-          </a:p>
-        </p:txBody>
-      </p:sp>
-      <p:sp>
-        <p:nvSpPr>
-          <p:cNvPr id="5" name="TextBox 4"/>
-          <p:cNvSpPr txBox="1"/>
-          <p:nvPr/>
-        </p:nvSpPr>
-        <p:spPr>
-          <a:xfrm>
-            <a:off x="1325880" y="3648456"/>
-            <a:ext cx="9555480" cy="658368"/>
-          </a:xfrm>
-          <a:prstGeom prst="rect">
-            <a:avLst/>
-          </a:prstGeom>
-          <a:noFill/>
-        </p:spPr>
-        <p:txBody>
-          <a:bodyPr wrap="square">
-            <a:spAutoFit/>
-          </a:bodyPr>
-          <a:lstStyle/>
-          <a:p>
-            <a:pPr algn="l"/>
-            <a:r>
-              <a:rPr sz="1800" b="0">
-                <a:solidFill>
-                  <a:srgbClr val="FFFFFF"/>
-                </a:solidFill>
-              </a:rPr>
-              <a:t>• Name outputs consistently so later tool calls can target objects, layers, and exports</a:t>
-            </a:r>
-          </a:p>
-        </p:txBody>
-      </p:sp>
-      <p:sp>
-        <p:nvSpPr>
-          <p:cNvPr id="6" name="TextBox 5"/>
-          <p:cNvSpPr txBox="1"/>
-          <p:nvPr/>
-        </p:nvSpPr>
-        <p:spPr>
-          <a:xfrm>
-            <a:off x="1325880" y="4398264"/>
-            <a:ext cx="9555480" cy="658368"/>
-          </a:xfrm>
-          <a:prstGeom prst="rect">
-            <a:avLst/>
-          </a:prstGeom>
-          <a:noFill/>
-        </p:spPr>
-        <p:txBody>
-          <a:bodyPr wrap="square">
-            <a:spAutoFit/>
-          </a:bodyPr>
-          <a:lstStyle/>
-          <a:p>
-            <a:pPr algn="l"/>
-            <a:r>
-              <a:rPr sz="1800" b="0">
-                <a:solidFill>
-                  <a:srgbClr val="FFFFFF"/>
-                </a:solidFill>
-              </a:rPr>
-              <a:t>• Add a fallback model path so a Claude outage does not stop the whole creative pipeline</a:t>
-            </a:r>
-          </a:p>
-        </p:txBody>
-      </p:sp>
-      <p:sp>
-        <p:nvSpPr>
-          <p:cNvPr id="7" name="TextBox 6"/>
-          <p:cNvSpPr txBox="1"/>
-          <p:nvPr/>
-        </p:nvSpPr>
-        <p:spPr>
-          <a:xfrm>
-            <a:off x="731520" y="5440680"/>
-            <a:ext cx="10698480" cy="502920"/>
-          </a:xfrm>
-          <a:prstGeom prst="rect">
-            <a:avLst/>
-          </a:prstGeom>
-          <a:noFill/>
-        </p:spPr>
-        <p:txBody>
-          <a:bodyPr wrap="square">
-            <a:spAutoFit/>
-          </a:bodyPr>
-          <a:lstStyle/>
-          <a:p>
-            <a:pPr algn="ctr"/>
-            <a:r>
-              <a:rPr sz="2000" b="1">
-                <a:solidFill>
-                  <a:srgbClr val="A1A1AA"/>
-                </a:solidFill>
-              </a:rPr>
-              <a:t>Read the full chapter · academy.kspl.tech</a:t>
-            </a:r>
-          </a:p>
-        </p:txBody>
-      </p:sp>
-      <p:sp>
-        <p:nvSpPr>
-          <p:cNvPr id="8" name="TextBox 7"/>
-          <p:cNvSpPr txBox="1"/>
-          <p:nvPr/>
-        </p:nvSpPr>
-        <p:spPr>
-          <a:xfrm>
-            <a:off x="731520" y="6272784"/>
-            <a:ext cx="10789920" cy="274320"/>
+            <a:off x="731520" y="6263640"/>
+            <a:ext cx="10698480" cy="365760"/>
           </a:xfrm>
           <a:prstGeom prst="rect">
             <a:avLst/>

</xml_diff>

<commit_message>
fix(issues): require both g5_verified_at and g5_verdict for ownership bypass; add deny tests; remove unrelated PR files
- isG5DoneMetadataPatch now requires both keys to be present before
  allowing the G5 done-artifact ownership bypass, preventing a partial
  metadataPatch (only g5_verified_at or only g5_verdict) from bypassing
  ownership checks without a complete machine-readable verdict
- Added two deny-path tests: G5 comment + only g5_verified_at → 403;
  G5 comment + only g5_verdict → 403
- Reverted vault/blogs, vault/courses/ch07-slides.pptx, and
  07-creative-connectors-meta.yaml to master state to remove unrelated
  changes from the PR scope

Addresses G_code REQUEST_CHANGES on PR #39.
</commit_message>
<xml_diff>
--- a/vault/courses/claude-tool-use-from-zero/ch07-slides.pptx
+++ b/vault/courses/claude-tool-use-from-zero/ch07-slides.pptx
@@ -3110,8 +3110,8 @@
         </p:nvSpPr>
         <p:spPr>
           <a:xfrm>
-            <a:off x="914400" y="1828800"/>
-            <a:ext cx="10332720" cy="2286000"/>
+            <a:off x="731520" y="1417320"/>
+            <a:ext cx="10744200" cy="1920240"/>
           </a:xfrm>
           <a:prstGeom prst="rect">
             <a:avLst/>
@@ -3131,7 +3131,7 @@
                   <a:srgbClr val="FFFFFF"/>
                 </a:solidFill>
               </a:rPr>
-              <a:t>Creative Connectors</a:t>
+              <a:t>How to use Claude's creative connectors for Blender and Adobe for creativity</a:t>
             </a:r>
           </a:p>
         </p:txBody>
@@ -3144,8 +3144,76 @@
         </p:nvSpPr>
         <p:spPr>
           <a:xfrm>
-            <a:off x="731520" y="6263640"/>
-            <a:ext cx="10698480" cy="365760"/>
+            <a:off x="731520" y="3611880"/>
+            <a:ext cx="10744200" cy="457200"/>
+          </a:xfrm>
+          <a:prstGeom prst="rect">
+            <a:avLst/>
+          </a:prstGeom>
+          <a:noFill/>
+        </p:spPr>
+        <p:txBody>
+          <a:bodyPr wrap="square">
+            <a:spAutoFit/>
+          </a:bodyPr>
+          <a:lstStyle/>
+          <a:p>
+            <a:pPr algn="ctr"/>
+            <a:r>
+              <a:rPr sz="1700" b="0">
+                <a:solidFill>
+                  <a:srgbClr val="A1A1AA"/>
+                </a:solidFill>
+              </a:rPr>
+              <a:t>Chapter 7 · Claude Tool Use from Zero</a:t>
+            </a:r>
+          </a:p>
+        </p:txBody>
+      </p:sp>
+      <p:sp>
+        <p:nvSpPr>
+          <p:cNvPr id="4" name="TextBox 3"/>
+          <p:cNvSpPr txBox="1"/>
+          <p:nvPr/>
+        </p:nvSpPr>
+        <p:spPr>
+          <a:xfrm>
+            <a:off x="1234440" y="4343400"/>
+            <a:ext cx="9784080" cy="731520"/>
+          </a:xfrm>
+          <a:prstGeom prst="rect">
+            <a:avLst/>
+          </a:prstGeom>
+          <a:noFill/>
+        </p:spPr>
+        <p:txBody>
+          <a:bodyPr wrap="square">
+            <a:spAutoFit/>
+          </a:bodyPr>
+          <a:lstStyle/>
+          <a:p>
+            <a:pPr algn="ctr"/>
+            <a:r>
+              <a:rPr sz="1800" b="0">
+                <a:solidFill>
+                  <a:srgbClr val="D4D4D8"/>
+                </a:solidFill>
+              </a:rPr>
+              <a:t>Blender execution, Adobe pipelines, connector selection, and resilient fallback design</a:t>
+            </a:r>
+          </a:p>
+        </p:txBody>
+      </p:sp>
+      <p:sp>
+        <p:nvSpPr>
+          <p:cNvPr id="5" name="TextBox 4"/>
+          <p:cNvSpPr txBox="1"/>
+          <p:nvPr/>
+        </p:nvSpPr>
+        <p:spPr>
+          <a:xfrm>
+            <a:off x="731520" y="6272784"/>
+            <a:ext cx="10789920" cy="274320"/>
           </a:xfrm>
           <a:prstGeom prst="rect">
             <a:avLst/>
@@ -3205,7 +3273,7 @@
         <p:spPr>
           <a:xfrm>
             <a:off x="731520" y="411480"/>
-            <a:ext cx="10698480" cy="1005840"/>
+            <a:ext cx="10698480" cy="685800"/>
           </a:xfrm>
           <a:prstGeom prst="rect">
             <a:avLst/>
@@ -3225,7 +3293,7 @@
                   <a:srgbClr val="FFFFFF"/>
                 </a:solidFill>
               </a:rPr>
-              <a:t>Key facts</a:t>
+              <a:t>Why Creative Connectors Matter</a:t>
             </a:r>
           </a:p>
         </p:txBody>
@@ -3238,8 +3306,8 @@
         </p:nvSpPr>
         <p:spPr>
           <a:xfrm>
-            <a:off x="731520" y="1417320"/>
-            <a:ext cx="10698480" cy="36576"/>
+            <a:off x="731520" y="1234440"/>
+            <a:ext cx="10698480" cy="32004"/>
           </a:xfrm>
           <a:prstGeom prst="rect">
             <a:avLst/>
@@ -3281,8 +3349,8 @@
         </p:nvSpPr>
         <p:spPr>
           <a:xfrm>
-            <a:off x="731520" y="1600200"/>
-            <a:ext cx="10698480" cy="960120"/>
+            <a:off x="914400" y="1572768"/>
+            <a:ext cx="10149840" cy="658368"/>
           </a:xfrm>
           <a:prstGeom prst="rect">
             <a:avLst/>
@@ -3297,12 +3365,12 @@
           <a:p>
             <a:pPr algn="l"/>
             <a:r>
-              <a:rPr sz="1700" b="0">
+              <a:rPr sz="1800" b="0">
                 <a:solidFill>
                   <a:srgbClr val="FFFFFF"/>
                 </a:solidFill>
               </a:rPr>
-              <a:t>  Nine initial connectors: The launch includes Blender, Adobe for creativity, Ableton Live, Affinity by Canva, Autodesk Fusion, SketchUp, Reso</a:t>
+              <a:t>• Anthropic launched nine creative MCP connectors spanning 3D, design, audio, CAD, live visuals, and samples</a:t>
             </a:r>
           </a:p>
         </p:txBody>
@@ -3315,8 +3383,8 @@
         </p:nvSpPr>
         <p:spPr>
           <a:xfrm>
-            <a:off x="731520" y="2651760"/>
-            <a:ext cx="10698480" cy="960120"/>
+            <a:off x="914400" y="2414016"/>
+            <a:ext cx="10149840" cy="658368"/>
           </a:xfrm>
           <a:prstGeom prst="rect">
             <a:avLst/>
@@ -3331,12 +3399,12 @@
           <a:p>
             <a:pPr algn="l"/>
             <a:r>
-              <a:rPr sz="1700" b="0">
+              <a:rPr sz="1800" b="0">
                 <a:solidFill>
                   <a:srgbClr val="FFFFFF"/>
                 </a:solidFill>
               </a:rPr>
-              <a:t>  Live scene execution: Unlike static file parsing, connectors like Blender allow Claude to execute code (via bpy) against the live scene stat</a:t>
+              <a:t>• Creative apps have high syntax barriers, which makes tool-use wins visible quickly</a:t>
             </a:r>
           </a:p>
         </p:txBody>
@@ -3349,8 +3417,8 @@
         </p:nvSpPr>
         <p:spPr>
           <a:xfrm>
-            <a:off x="731520" y="3703320"/>
-            <a:ext cx="10698480" cy="960120"/>
+            <a:off x="914400" y="3255264"/>
+            <a:ext cx="10149840" cy="658368"/>
           </a:xfrm>
           <a:prstGeom prst="rect">
             <a:avLst/>
@@ -3365,12 +3433,12 @@
           <a:p>
             <a:pPr algn="l"/>
             <a:r>
-              <a:rPr sz="1700" b="0">
+              <a:rPr sz="1800" b="0">
                 <a:solidFill>
                   <a:srgbClr val="FFFFFF"/>
                 </a:solidFill>
               </a:rPr>
-              <a:t>  Local-first architecture: The connectors run as local MCP servers, meaning your creative assets stay on your machine while Claude only sends</a:t>
+              <a:t>• Local MCP servers keep asset operations close to the machine running the professional software</a:t>
             </a:r>
           </a:p>
         </p:txBody>
@@ -3383,8 +3451,8 @@
         </p:nvSpPr>
         <p:spPr>
           <a:xfrm>
-            <a:off x="731520" y="4754880"/>
-            <a:ext cx="10698480" cy="960120"/>
+            <a:off x="914400" y="4096512"/>
+            <a:ext cx="10149840" cy="658368"/>
           </a:xfrm>
           <a:prstGeom prst="rect">
             <a:avLst/>
@@ -3399,12 +3467,12 @@
           <a:p>
             <a:pPr algn="l"/>
             <a:r>
-              <a:rPr sz="1700" b="0">
+              <a:rPr sz="1800" b="0">
                 <a:solidFill>
                   <a:srgbClr val="FFFFFF"/>
                 </a:solidFill>
               </a:rPr>
-              <a:t>  Free and Paid Tiers: While many features (like Adobe Express) are available on free plans, advanced API access for tools like Photoshop typi</a:t>
+              <a:t>• Cross-app workflows turn Claude into coordination infrastructure for fragmented creative suites</a:t>
             </a:r>
           </a:p>
         </p:txBody>
@@ -3417,8 +3485,8 @@
         </p:nvSpPr>
         <p:spPr>
           <a:xfrm>
-            <a:off x="731520" y="6263640"/>
-            <a:ext cx="10698480" cy="365760"/>
+            <a:off x="731520" y="6272784"/>
+            <a:ext cx="10789920" cy="274320"/>
           </a:xfrm>
           <a:prstGeom prst="rect">
             <a:avLst/>
@@ -3478,7 +3546,7 @@
         <p:spPr>
           <a:xfrm>
             <a:off x="731520" y="411480"/>
-            <a:ext cx="10698480" cy="1005840"/>
+            <a:ext cx="10698480" cy="685800"/>
           </a:xfrm>
           <a:prstGeom prst="rect">
             <a:avLst/>
@@ -3498,7 +3566,7 @@
                   <a:srgbClr val="FFFFFF"/>
                 </a:solidFill>
               </a:rPr>
-              <a:t>Why Anthropic chose creative apps first</a:t>
+              <a:t>Blender MCP: Live Scene Execution</a:t>
             </a:r>
           </a:p>
         </p:txBody>
@@ -3511,8 +3579,8 @@
         </p:nvSpPr>
         <p:spPr>
           <a:xfrm>
-            <a:off x="731520" y="1417320"/>
-            <a:ext cx="10698480" cy="36576"/>
+            <a:off x="731520" y="1234440"/>
+            <a:ext cx="10698480" cy="32004"/>
           </a:xfrm>
           <a:prstGeom prst="rect">
             <a:avLst/>
@@ -3554,8 +3622,8 @@
         </p:nvSpPr>
         <p:spPr>
           <a:xfrm>
-            <a:off x="731520" y="1600200"/>
-            <a:ext cx="10698480" cy="960120"/>
+            <a:off x="914400" y="1572768"/>
+            <a:ext cx="10149840" cy="658368"/>
           </a:xfrm>
           <a:prstGeom prst="rect">
             <a:avLst/>
@@ -3570,12 +3638,12 @@
           <a:p>
             <a:pPr algn="l"/>
             <a:r>
-              <a:rPr sz="1700" b="0">
+              <a:rPr sz="1800" b="0">
                 <a:solidFill>
                   <a:srgbClr val="FFFFFF"/>
                 </a:solidFill>
               </a:rPr>
-              <a:t>  Most AI providers chase enterprise CRM and ERP integrations. Anthropic’s pivot to creative tools is non-obvious but brilliant for three reas</a:t>
+              <a:t>• The Blender connector exposes Blender Python through an MCP tool interface</a:t>
             </a:r>
           </a:p>
         </p:txBody>
@@ -3588,8 +3656,8 @@
         </p:nvSpPr>
         <p:spPr>
           <a:xfrm>
-            <a:off x="731520" y="2651760"/>
-            <a:ext cx="10698480" cy="960120"/>
+            <a:off x="914400" y="2414016"/>
+            <a:ext cx="10149840" cy="658368"/>
           </a:xfrm>
           <a:prstGeom prst="rect">
             <a:avLst/>
@@ -3604,12 +3672,12 @@
           <a:p>
             <a:pPr algn="l"/>
             <a:r>
-              <a:rPr sz="1700" b="0">
+              <a:rPr sz="1800" b="0">
                 <a:solidFill>
                   <a:srgbClr val="FFFFFF"/>
                 </a:solidFill>
               </a:rPr>
-              <a:t>  High Syntax Barrier: Writing bpy (Blender Python) or ExtendScript (Adobe) is notoriously difficult for humans but easy for LLMs. This create</a:t>
+              <a:t>• Claude sends structured execute_python calls that run inside Blender against live scene state</a:t>
             </a:r>
           </a:p>
         </p:txBody>
@@ -3622,8 +3690,8 @@
         </p:nvSpPr>
         <p:spPr>
           <a:xfrm>
-            <a:off x="731520" y="3703320"/>
-            <a:ext cx="10698480" cy="960120"/>
+            <a:off x="914400" y="3255264"/>
+            <a:ext cx="10149840" cy="658368"/>
           </a:xfrm>
           <a:prstGeom prst="rect">
             <a:avLst/>
@@ -3638,12 +3706,12 @@
           <a:p>
             <a:pPr algn="l"/>
             <a:r>
-              <a:rPr sz="1700" b="0">
+              <a:rPr sz="1800" b="0">
                 <a:solidFill>
                   <a:srgbClr val="FFFFFF"/>
                 </a:solidFill>
               </a:rPr>
-              <a:t>  Low Risk, High Visibility: A bug in a generative 3D script is a creative glitch; a bug in a Salesforce integration is a business catastrophe</a:t>
+              <a:t>• A safe first step is a read-only query that lists scene objects and types</a:t>
             </a:r>
           </a:p>
         </p:txBody>
@@ -3656,8 +3724,8 @@
         </p:nvSpPr>
         <p:spPr>
           <a:xfrm>
-            <a:off x="731520" y="4754880"/>
-            <a:ext cx="10698480" cy="960120"/>
+            <a:off x="914400" y="4096512"/>
+            <a:ext cx="10149840" cy="658368"/>
           </a:xfrm>
           <a:prstGeom prst="rect">
             <a:avLst/>
@@ -3672,12 +3740,12 @@
           <a:p>
             <a:pPr algn="l"/>
             <a:r>
-              <a:rPr sz="1700" b="0">
+              <a:rPr sz="1800" b="0">
                 <a:solidFill>
                   <a:srgbClr val="FFFFFF"/>
                 </a:solidFill>
               </a:rPr>
-              <a:t>  Synthesizing the Pipeline: Creative work is rarely done in one app. By winning the "bridge" between Blender and Photoshop, Anthropic positio</a:t>
+              <a:t>• Procedural generation becomes repeatable when scripts use stable collections and object names</a:t>
             </a:r>
           </a:p>
         </p:txBody>
@@ -3690,8 +3758,8 @@
         </p:nvSpPr>
         <p:spPr>
           <a:xfrm>
-            <a:off x="731520" y="6263640"/>
-            <a:ext cx="10698480" cy="365760"/>
+            <a:off x="731520" y="6272784"/>
+            <a:ext cx="10789920" cy="274320"/>
           </a:xfrm>
           <a:prstGeom prst="rect">
             <a:avLst/>
@@ -3751,7 +3819,7 @@
         <p:spPr>
           <a:xfrm>
             <a:off x="731520" y="411480"/>
-            <a:ext cx="10698480" cy="1005840"/>
+            <a:ext cx="10698480" cy="685800"/>
           </a:xfrm>
           <a:prstGeom prst="rect">
             <a:avLst/>
@@ -3771,7 +3839,7 @@
                   <a:srgbClr val="FFFFFF"/>
                 </a:solidFill>
               </a:rPr>
-              <a:t>Walkthrough: Controlling Blender via MCP</a:t>
+              <a:t>Adobe For Creativity: Locate, Edit, Export</a:t>
             </a:r>
           </a:p>
         </p:txBody>
@@ -3784,8 +3852,8 @@
         </p:nvSpPr>
         <p:spPr>
           <a:xfrm>
-            <a:off x="731520" y="1417320"/>
-            <a:ext cx="10698480" cy="36576"/>
+            <a:off x="731520" y="1234440"/>
+            <a:ext cx="10698480" cy="32004"/>
           </a:xfrm>
           <a:prstGeom prst="rect">
             <a:avLst/>
@@ -3827,8 +3895,8 @@
         </p:nvSpPr>
         <p:spPr>
           <a:xfrm>
-            <a:off x="731520" y="1600200"/>
-            <a:ext cx="10698480" cy="960120"/>
+            <a:off x="914400" y="1572768"/>
+            <a:ext cx="10149840" cy="658368"/>
           </a:xfrm>
           <a:prstGeom prst="rect">
             <a:avLst/>
@@ -3843,12 +3911,12 @@
           <a:p>
             <a:pPr algn="l"/>
             <a:r>
-              <a:rPr sz="1700" b="0">
+              <a:rPr sz="1800" b="0">
                 <a:solidFill>
                   <a:srgbClr val="FFFFFF"/>
                 </a:solidFill>
               </a:rPr>
-              <a:t>  The Blender connector is the most technically transparent of Anthropic's nine creative integrations. Unlike connectors that wrap proprietary</a:t>
+              <a:t>• The Adobe connector wraps multiple creative applications under one tool-use surface</a:t>
             </a:r>
           </a:p>
         </p:txBody>
@@ -3861,8 +3929,8 @@
         </p:nvSpPr>
         <p:spPr>
           <a:xfrm>
-            <a:off x="731520" y="2651760"/>
-            <a:ext cx="10698480" cy="960120"/>
+            <a:off x="914400" y="2414016"/>
+            <a:ext cx="10149840" cy="658368"/>
           </a:xfrm>
           <a:prstGeom prst="rect">
             <a:avLst/>
@@ -3877,12 +3945,12 @@
           <a:p>
             <a:pPr algn="l"/>
             <a:r>
-              <a:rPr sz="1700" b="0">
+              <a:rPr sz="1800" b="0">
                 <a:solidFill>
                   <a:srgbClr val="FFFFFF"/>
                 </a:solidFill>
               </a:rPr>
-              <a:t>  How the connection works</a:t>
+              <a:t>• A pipeline can search a Library asset, open it in Photoshop, apply a Smart Filter, and export a JPEG</a:t>
             </a:r>
           </a:p>
         </p:txBody>
@@ -3895,8 +3963,8 @@
         </p:nvSpPr>
         <p:spPr>
           <a:xfrm>
-            <a:off x="731520" y="3703320"/>
-            <a:ext cx="10698480" cy="960120"/>
+            <a:off x="914400" y="3255264"/>
+            <a:ext cx="10149840" cy="658368"/>
           </a:xfrm>
           <a:prstGeom prst="rect">
             <a:avLst/>
@@ -3911,12 +3979,12 @@
           <a:p>
             <a:pPr algn="l"/>
             <a:r>
-              <a:rPr sz="1700" b="0">
+              <a:rPr sz="1800" b="0">
                 <a:solidFill>
                   <a:srgbClr val="FFFFFF"/>
                 </a:solidFill>
               </a:rPr>
-              <a:t>  Before touching any code, it helps to have a mental model of the data flow.</a:t>
+              <a:t>• Smart Objects keep edits non-destructive so filters remain adjustable later</a:t>
             </a:r>
           </a:p>
         </p:txBody>
@@ -3929,8 +3997,8 @@
         </p:nvSpPr>
         <p:spPr>
           <a:xfrm>
-            <a:off x="731520" y="4754880"/>
-            <a:ext cx="10698480" cy="960120"/>
+            <a:off x="914400" y="4096512"/>
+            <a:ext cx="10149840" cy="658368"/>
           </a:xfrm>
           <a:prstGeom prst="rect">
             <a:avLst/>
@@ -3945,12 +4013,12 @@
           <a:p>
             <a:pPr algn="l"/>
             <a:r>
-              <a:rPr sz="1700" b="0">
+              <a:rPr sz="1800" b="0">
                 <a:solidFill>
                   <a:srgbClr val="FFFFFF"/>
                 </a:solidFill>
               </a:rPr>
-              <a:t>  You (natural language)</a:t>
+              <a:t>• Plan subscriptions matter: Adobe Express can be free, while Photoshop and Library write flows usually need paid access</a:t>
             </a:r>
           </a:p>
         </p:txBody>
@@ -3963,8 +4031,8 @@
         </p:nvSpPr>
         <p:spPr>
           <a:xfrm>
-            <a:off x="731520" y="6263640"/>
-            <a:ext cx="10698480" cy="365760"/>
+            <a:off x="731520" y="6272784"/>
+            <a:ext cx="10789920" cy="274320"/>
           </a:xfrm>
           <a:prstGeom prst="rect">
             <a:avLst/>
@@ -4024,7 +4092,7 @@
         <p:spPr>
           <a:xfrm>
             <a:off x="731520" y="411480"/>
-            <a:ext cx="10698480" cy="1005840"/>
+            <a:ext cx="10698480" cy="685800"/>
           </a:xfrm>
           <a:prstGeom prst="rect">
             <a:avLst/>
@@ -4044,7 +4112,7 @@
                   <a:srgbClr val="FFFFFF"/>
                 </a:solidFill>
               </a:rPr>
-              <a:t>Walkthrough: Multi-tool pipelines with Adobe for creativity</a:t>
+              <a:t>Choosing The Right Connector</a:t>
             </a:r>
           </a:p>
         </p:txBody>
@@ -4057,8 +4125,8 @@
         </p:nvSpPr>
         <p:spPr>
           <a:xfrm>
-            <a:off x="731520" y="1417320"/>
-            <a:ext cx="10698480" cy="36576"/>
+            <a:off x="731520" y="1234440"/>
+            <a:ext cx="10698480" cy="32004"/>
           </a:xfrm>
           <a:prstGeom prst="rect">
             <a:avLst/>
@@ -4100,8 +4168,8 @@
         </p:nvSpPr>
         <p:spPr>
           <a:xfrm>
-            <a:off x="731520" y="1600200"/>
-            <a:ext cx="10698480" cy="960120"/>
+            <a:off x="914400" y="1572768"/>
+            <a:ext cx="10149840" cy="658368"/>
           </a:xfrm>
           <a:prstGeom prst="rect">
             <a:avLst/>
@@ -4116,12 +4184,12 @@
           <a:p>
             <a:pPr algn="l"/>
             <a:r>
-              <a:rPr sz="1700" b="0">
+              <a:rPr sz="1800" b="0">
                 <a:solidFill>
                   <a:srgbClr val="FFFFFF"/>
                 </a:solidFill>
               </a:rPr>
-              <a:t>  Adobe for creativity is the broadest integration in Anthropic's creative connector lineup: a broad collection of tools across photo editing,</a:t>
+              <a:t>• Use Blender for generative scenes and procedural 3D work driven by Python APIs</a:t>
             </a:r>
           </a:p>
         </p:txBody>
@@ -4134,8 +4202,8 @@
         </p:nvSpPr>
         <p:spPr>
           <a:xfrm>
-            <a:off x="731520" y="2651760"/>
-            <a:ext cx="10698480" cy="960120"/>
+            <a:off x="914400" y="2414016"/>
+            <a:ext cx="10149840" cy="658368"/>
           </a:xfrm>
           <a:prstGeom prst="rect">
             <a:avLst/>
@@ -4150,12 +4218,12 @@
           <a:p>
             <a:pPr algn="l"/>
             <a:r>
-              <a:rPr sz="1700" b="0">
+              <a:rPr sz="1800" b="0">
                 <a:solidFill>
                   <a:srgbClr val="FFFFFF"/>
                 </a:solidFill>
               </a:rPr>
-              <a:t>  What requires a paid plan</a:t>
+              <a:t>• Use Adobe or Affinity when the workflow centers on design assets, layers, batches, or exports</a:t>
             </a:r>
           </a:p>
         </p:txBody>
@@ -4168,8 +4236,8 @@
         </p:nvSpPr>
         <p:spPr>
           <a:xfrm>
-            <a:off x="731520" y="3703320"/>
-            <a:ext cx="10698480" cy="960120"/>
+            <a:off x="914400" y="3255264"/>
+            <a:ext cx="10149840" cy="658368"/>
           </a:xfrm>
           <a:prstGeom prst="rect">
             <a:avLst/>
@@ -4184,12 +4252,12 @@
           <a:p>
             <a:pPr algn="l"/>
             <a:r>
-              <a:rPr sz="1700" b="0">
+              <a:rPr sz="1800" b="0">
                 <a:solidFill>
                   <a:srgbClr val="FFFFFF"/>
                 </a:solidFill>
               </a:rPr>
-              <a:t>  Multi-tool flow: locate → edit → export</a:t>
+              <a:t>• Use Fusion or SketchUp when precision geometry and CAD constraints are the core task</a:t>
             </a:r>
           </a:p>
         </p:txBody>
@@ -4202,8 +4270,8 @@
         </p:nvSpPr>
         <p:spPr>
           <a:xfrm>
-            <a:off x="731520" y="4754880"/>
-            <a:ext cx="10698480" cy="960120"/>
+            <a:off x="914400" y="4096512"/>
+            <a:ext cx="10149840" cy="658368"/>
           </a:xfrm>
           <a:prstGeom prst="rect">
             <a:avLst/>
@@ -4218,12 +4286,12 @@
           <a:p>
             <a:pPr algn="l"/>
             <a:r>
-              <a:rPr sz="1700" b="0">
+              <a:rPr sz="1800" b="0">
                 <a:solidFill>
                   <a:srgbClr val="FFFFFF"/>
                 </a:solidFill>
               </a:rPr>
-              <a:t>  Each step here is a separate tool call; Claude sequences them automatically based on context.</a:t>
+              <a:t>• Use Ableton, Splice, or Resolume when the asset is audio, samples, or live visual performance state</a:t>
             </a:r>
           </a:p>
         </p:txBody>
@@ -4236,8 +4304,8 @@
         </p:nvSpPr>
         <p:spPr>
           <a:xfrm>
-            <a:off x="731520" y="6263640"/>
-            <a:ext cx="10698480" cy="365760"/>
+            <a:off x="731520" y="6272784"/>
+            <a:ext cx="10789920" cy="274320"/>
           </a:xfrm>
           <a:prstGeom prst="rect">
             <a:avLst/>
@@ -4297,7 +4365,7 @@
         <p:spPr>
           <a:xfrm>
             <a:off x="731520" y="411480"/>
-            <a:ext cx="10698480" cy="1005840"/>
+            <a:ext cx="10698480" cy="685800"/>
           </a:xfrm>
           <a:prstGeom prst="rect">
             <a:avLst/>
@@ -4317,7 +4385,7 @@
                   <a:srgbClr val="FFFFFF"/>
                 </a:solidFill>
               </a:rPr>
-              <a:t>Exploring the other creative connectors</a:t>
+              <a:t>Build Resilience Into Creative Pipelines</a:t>
             </a:r>
           </a:p>
         </p:txBody>
@@ -4330,8 +4398,8 @@
         </p:nvSpPr>
         <p:spPr>
           <a:xfrm>
-            <a:off x="731520" y="1417320"/>
-            <a:ext cx="10698480" cy="36576"/>
+            <a:off x="731520" y="1234440"/>
+            <a:ext cx="10698480" cy="32004"/>
           </a:xfrm>
           <a:prstGeom prst="rect">
             <a:avLst/>
@@ -4373,8 +4441,8 @@
         </p:nvSpPr>
         <p:spPr>
           <a:xfrm>
-            <a:off x="731520" y="1600200"/>
-            <a:ext cx="10698480" cy="960120"/>
+            <a:off x="914400" y="1572768"/>
+            <a:ext cx="10149840" cy="658368"/>
           </a:xfrm>
           <a:prstGeom prst="rect">
             <a:avLst/>
@@ -4389,12 +4457,12 @@
           <a:p>
             <a:pPr algn="l"/>
             <a:r>
-              <a:rPr sz="1700" b="0">
+              <a:rPr sz="1800" b="0">
                 <a:solidFill>
                   <a:srgbClr val="FFFFFF"/>
                 </a:solidFill>
               </a:rPr>
-              <a:t>  While Blender and Adobe for creativity are the flagship integrations, Anthropic launched a total of nine connectors targeting different crea</a:t>
+              <a:t>• Claude is a strong first-choice model, but single-provider dependency can halt production during outages</a:t>
             </a:r>
           </a:p>
         </p:txBody>
@@ -4407,8 +4475,8 @@
         </p:nvSpPr>
         <p:spPr>
           <a:xfrm>
-            <a:off x="731520" y="2651760"/>
-            <a:ext cx="10698480" cy="960120"/>
+            <a:off x="914400" y="2414016"/>
+            <a:ext cx="10149840" cy="658368"/>
           </a:xfrm>
           <a:prstGeom prst="rect">
             <a:avLst/>
@@ -4423,12 +4491,12 @@
           <a:p>
             <a:pPr algn="l"/>
             <a:r>
-              <a:rPr sz="1700" b="0">
+              <a:rPr sz="1800" b="0">
                 <a:solidFill>
                   <a:srgbClr val="FFFFFF"/>
                 </a:solidFill>
               </a:rPr>
-              <a:t>  Ableton Live: Automating the manual</a:t>
+              <a:t>• Keep MCP tool definitions provider-agnostic so fallback models can call the same tools</a:t>
             </a:r>
           </a:p>
         </p:txBody>
@@ -4441,8 +4509,8 @@
         </p:nvSpPr>
         <p:spPr>
           <a:xfrm>
-            <a:off x="731520" y="3703320"/>
-            <a:ext cx="10698480" cy="960120"/>
+            <a:off x="914400" y="3255264"/>
+            <a:ext cx="10149840" cy="658368"/>
           </a:xfrm>
           <a:prstGeom prst="rect">
             <a:avLst/>
@@ -4457,12 +4525,12 @@
           <a:p>
             <a:pPr algn="l"/>
             <a:r>
-              <a:rPr sz="1700" b="0">
+              <a:rPr sz="1800" b="0">
                 <a:solidFill>
                   <a:srgbClr val="FFFFFF"/>
                 </a:solidFill>
               </a:rPr>
-              <a:t>  The Ableton connector focuses on documentation and session management. It allows Claude to read session metadata (track names, clips, device</a:t>
+              <a:t>• Implement fallback explicitly in your gateway or application loop instead of assuming the SDK handles it</a:t>
             </a:r>
           </a:p>
         </p:txBody>
@@ -4475,8 +4543,8 @@
         </p:nvSpPr>
         <p:spPr>
           <a:xfrm>
-            <a:off x="731520" y="4754880"/>
-            <a:ext cx="10698480" cy="960120"/>
+            <a:off x="914400" y="4096512"/>
+            <a:ext cx="10149840" cy="658368"/>
           </a:xfrm>
           <a:prstGeom prst="rect">
             <a:avLst/>
@@ -4491,12 +4559,12 @@
           <a:p>
             <a:pPr algn="l"/>
             <a:r>
-              <a:rPr sz="1700" b="0">
+              <a:rPr sz="1800" b="0">
                 <a:solidFill>
                   <a:srgbClr val="FFFFFF"/>
                 </a:solidFill>
               </a:rPr>
-              <a:t>  Pattern: Read session → Analyze MIDI → Generate documentation/labels.</a:t>
+              <a:t>• Treat uptime, naming conventions, and auditability as part of the creative tool contract</a:t>
             </a:r>
           </a:p>
         </p:txBody>
@@ -4509,8 +4577,8 @@
         </p:nvSpPr>
         <p:spPr>
           <a:xfrm>
-            <a:off x="731520" y="6263640"/>
-            <a:ext cx="10698480" cy="365760"/>
+            <a:off x="731520" y="6272784"/>
+            <a:ext cx="10789920" cy="274320"/>
           </a:xfrm>
           <a:prstGeom prst="rect">
             <a:avLst/>
@@ -4569,8 +4637,8 @@
         </p:nvSpPr>
         <p:spPr>
           <a:xfrm>
-            <a:off x="914400" y="2011680"/>
-            <a:ext cx="10332720" cy="914400"/>
+            <a:off x="731520" y="914400"/>
+            <a:ext cx="10698480" cy="822960"/>
           </a:xfrm>
           <a:prstGeom prst="rect">
             <a:avLst/>
@@ -4603,8 +4671,8 @@
         </p:nvSpPr>
         <p:spPr>
           <a:xfrm>
-            <a:off x="914400" y="3200400"/>
-            <a:ext cx="10332720" cy="1097280"/>
+            <a:off x="1325880" y="2148840"/>
+            <a:ext cx="9555480" cy="658368"/>
           </a:xfrm>
           <a:prstGeom prst="rect">
             <a:avLst/>
@@ -4617,14 +4685,14 @@
           </a:bodyPr>
           <a:lstStyle/>
           <a:p>
-            <a:pPr algn="ctr"/>
-            <a:r>
-              <a:rPr sz="2000" b="0">
-                <a:solidFill>
-                  <a:srgbClr val="A1A1AA"/>
+            <a:pPr algn="l"/>
+            <a:r>
+              <a:rPr sz="1800" b="0">
+                <a:solidFill>
+                  <a:srgbClr val="FFFFFF"/>
                 </a:solidFill>
               </a:rPr>
-              <a:t>Deploy a gateway with RBAC, rate limits, and JSONL auditing</a:t>
+              <a:t>• Connect a creative tool in Claude and start with a read-only scene or asset query</a:t>
             </a:r>
           </a:p>
         </p:txBody>
@@ -4637,8 +4705,144 @@
         </p:nvSpPr>
         <p:spPr>
           <a:xfrm>
-            <a:off x="731520" y="6263640"/>
-            <a:ext cx="10698480" cy="365760"/>
+            <a:off x="1325880" y="2898648"/>
+            <a:ext cx="9555480" cy="658368"/>
+          </a:xfrm>
+          <a:prstGeom prst="rect">
+            <a:avLst/>
+          </a:prstGeom>
+          <a:noFill/>
+        </p:spPr>
+        <p:txBody>
+          <a:bodyPr wrap="square">
+            <a:spAutoFit/>
+          </a:bodyPr>
+          <a:lstStyle/>
+          <a:p>
+            <a:pPr algn="l"/>
+            <a:r>
+              <a:rPr sz="1800" b="0">
+                <a:solidFill>
+                  <a:srgbClr val="FFFFFF"/>
+                </a:solidFill>
+              </a:rPr>
+              <a:t>• Automate one repeatable production step before attempting a full multi-app workflow</a:t>
+            </a:r>
+          </a:p>
+        </p:txBody>
+      </p:sp>
+      <p:sp>
+        <p:nvSpPr>
+          <p:cNvPr id="5" name="TextBox 4"/>
+          <p:cNvSpPr txBox="1"/>
+          <p:nvPr/>
+        </p:nvSpPr>
+        <p:spPr>
+          <a:xfrm>
+            <a:off x="1325880" y="3648456"/>
+            <a:ext cx="9555480" cy="658368"/>
+          </a:xfrm>
+          <a:prstGeom prst="rect">
+            <a:avLst/>
+          </a:prstGeom>
+          <a:noFill/>
+        </p:spPr>
+        <p:txBody>
+          <a:bodyPr wrap="square">
+            <a:spAutoFit/>
+          </a:bodyPr>
+          <a:lstStyle/>
+          <a:p>
+            <a:pPr algn="l"/>
+            <a:r>
+              <a:rPr sz="1800" b="0">
+                <a:solidFill>
+                  <a:srgbClr val="FFFFFF"/>
+                </a:solidFill>
+              </a:rPr>
+              <a:t>• Name outputs consistently so later tool calls can target objects, layers, and exports</a:t>
+            </a:r>
+          </a:p>
+        </p:txBody>
+      </p:sp>
+      <p:sp>
+        <p:nvSpPr>
+          <p:cNvPr id="6" name="TextBox 5"/>
+          <p:cNvSpPr txBox="1"/>
+          <p:nvPr/>
+        </p:nvSpPr>
+        <p:spPr>
+          <a:xfrm>
+            <a:off x="1325880" y="4398264"/>
+            <a:ext cx="9555480" cy="658368"/>
+          </a:xfrm>
+          <a:prstGeom prst="rect">
+            <a:avLst/>
+          </a:prstGeom>
+          <a:noFill/>
+        </p:spPr>
+        <p:txBody>
+          <a:bodyPr wrap="square">
+            <a:spAutoFit/>
+          </a:bodyPr>
+          <a:lstStyle/>
+          <a:p>
+            <a:pPr algn="l"/>
+            <a:r>
+              <a:rPr sz="1800" b="0">
+                <a:solidFill>
+                  <a:srgbClr val="FFFFFF"/>
+                </a:solidFill>
+              </a:rPr>
+              <a:t>• Add a fallback model path so a Claude outage does not stop the whole creative pipeline</a:t>
+            </a:r>
+          </a:p>
+        </p:txBody>
+      </p:sp>
+      <p:sp>
+        <p:nvSpPr>
+          <p:cNvPr id="7" name="TextBox 6"/>
+          <p:cNvSpPr txBox="1"/>
+          <p:nvPr/>
+        </p:nvSpPr>
+        <p:spPr>
+          <a:xfrm>
+            <a:off x="731520" y="5440680"/>
+            <a:ext cx="10698480" cy="502920"/>
+          </a:xfrm>
+          <a:prstGeom prst="rect">
+            <a:avLst/>
+          </a:prstGeom>
+          <a:noFill/>
+        </p:spPr>
+        <p:txBody>
+          <a:bodyPr wrap="square">
+            <a:spAutoFit/>
+          </a:bodyPr>
+          <a:lstStyle/>
+          <a:p>
+            <a:pPr algn="ctr"/>
+            <a:r>
+              <a:rPr sz="2000" b="1">
+                <a:solidFill>
+                  <a:srgbClr val="A1A1AA"/>
+                </a:solidFill>
+              </a:rPr>
+              <a:t>Read the full chapter · academy.kspl.tech</a:t>
+            </a:r>
+          </a:p>
+        </p:txBody>
+      </p:sp>
+      <p:sp>
+        <p:nvSpPr>
+          <p:cNvPr id="8" name="TextBox 7"/>
+          <p:cNvSpPr txBox="1"/>
+          <p:nvPr/>
+        </p:nvSpPr>
+        <p:spPr>
+          <a:xfrm>
+            <a:off x="731520" y="6272784"/>
+            <a:ext cx="10789920" cy="274320"/>
           </a:xfrm>
           <a:prstGeom prst="rect">
             <a:avLst/>

</xml_diff>